<commit_message>
Refine all-variant analysis: clean OR/WA samples, level-vs-bias model, UT diagnosis
Fixed hardcoded sample seed: OR/WA variants (BM/EC/PN/WC) had a pathological draw
inflating RMSE to ~98%; clean multi-sample values are ~47-50% and near-neutral. Conclusion
holds: calibrated <= native in 19/20, level 0.6-2.0 (median 1.2). Added level-vs-native-bias
model (r=-0.35: the level compensates for native mortality) and the Utah exception (weakest
self-thinning signal, drought-governed). Updated report, deck, doc, figures.
</commit_message>
<xml_diff>
--- a/calibration/sdimax/FVS_team_UPDATE_3step_plan.pptx
+++ b/calibration/sdimax/FVS_team_UPDATE_3step_plan.pptx
@@ -5509,7 +5509,7 @@
               <a:buNone/>
             </a:pPr>
             <a:r>
-              <a:rPr lang="en-US" sz="1300" i="1" dirty="0">
+              <a:rPr lang="en-US" sz="1250" i="1" dirty="0">
                 <a:solidFill>
                   <a:srgbClr val="666666"/>
                 </a:solidFill>
@@ -5517,9 +5517,9 @@
                 <a:ea typeface="Aptos" pitchFamily="34" charset="-122"/>
                 <a:cs typeface="Aptos" pitchFamily="34" charset="-120"/>
               </a:rPr>
-              <a:t>Each variant needs its own level (0.6 to 2.0, median 1.2), calibrated jointly with its mortality, not a uniform drop-in</a:t>
-            </a:r>
-            <a:endParaRPr lang="en-US" sz="1300" dirty="0"/>
+              <a:t>Each variant needs its own level (0.6 to 2.0, median 1.2); the level tracks its native bias, so it is calibrated jointly with mortality, not dropped in uniformly</a:t>
+            </a:r>
+            <a:endParaRPr lang="en-US" sz="1250" dirty="0"/>
           </a:p>
         </p:txBody>
       </p:sp>

</xml_diff>

<commit_message>
Stress test + honesty pass on materials and implementation status
Adversarial review of all claims: max-SDI self-thinning result is most robust but a relative
gain on a weak signal; all-variant magnitudes need multi-seed reruns (fixed-seed bug);
calibration coverage is partial (mortality all variants, growth partial/absent); NE benchmark
needs re-verification; injection untested. Reworded deck + document to true strength; added
stress-test and implementation-status memos.
</commit_message>
<xml_diff>
--- a/calibration/sdimax/FVS_team_UPDATE_3step_plan.pptx
+++ b/calibration/sdimax/FVS_team_UPDATE_3step_plan.pptx
@@ -2655,7 +2655,7 @@
             <a:avLst/>
           </a:prstGeom>
           <a:solidFill>
-            <a:srgbClr val="1A3D28"/>
+            <a:srgbClr val="C5A55A"/>
           </a:solidFill>
           <a:ln/>
         </p:spPr>
@@ -2732,7 +2732,7 @@
                 <a:ea typeface="Aptos" pitchFamily="34" charset="-122"/>
                 <a:cs typeface="Aptos" pitchFamily="34" charset="-120"/>
               </a:rPr>
-              <a:t>Working and benchmarked; deployable on the current engine</a:t>
+              <a:t>Mortality, crown, height-diameter calibrated for all 25 variants; growth multipliers still being completed</a:t>
             </a:r>
             <a:endParaRPr lang="en-US" sz="1500" dirty="0"/>
           </a:p>
@@ -2773,7 +2773,7 @@
             <a:avLst/>
           </a:prstGeom>
           <a:solidFill>
-            <a:srgbClr val="1A3D28"/>
+            <a:srgbClr val="C5A55A"/>
           </a:solidFill>
           <a:ln/>
         </p:spPr>
@@ -2850,7 +2850,7 @@
                 <a:ea typeface="Aptos" pitchFamily="34" charset="-122"/>
                 <a:cs typeface="Aptos" pitchFamily="34" charset="-120"/>
               </a:rPr>
-              <a:t>Validated across all 20 variants; ready to adopt jointly with mortality</a:t>
+              <a:t>Validated in analysis as a better self-thinning predictor; not yet in production config; adopt jointly with mortality</a:t>
             </a:r>
             <a:endParaRPr lang="en-US" sz="1500" dirty="0"/>
           </a:p>
@@ -2968,7 +2968,7 @@
                 <a:ea typeface="Aptos" pitchFamily="34" charset="-122"/>
                 <a:cs typeface="Aptos" pitchFamily="34" charset="-120"/>
               </a:rPr>
-              <a:t>Components built, stand-level prototyped; engine injection is the next task</a:t>
+              <a:t>Equations fit and banked; engine injection prototyped, not merged</a:t>
             </a:r>
             <a:endParaRPr lang="en-US" sz="1500" dirty="0"/>
           </a:p>
@@ -3501,7 +3501,7 @@
                 <a:ea typeface="Aptos" pitchFamily="34" charset="-122"/>
                 <a:cs typeface="Aptos" pitchFamily="34" charset="-120"/>
               </a:rPr>
-              <a:t>Layer FIA-derived calibration modifiers (mortality, growth, density limit) onto the existing FVS engine. Deployable now; this is the basis of fvs-modern.</a:t>
+              <a:t>Layer FIA-derived calibration modifiers (mortality, growth, density limit) onto the existing FVS engine. The basis of fvs-modern.</a:t>
             </a:r>
             <a:endParaRPr lang="en-US" sz="1400" dirty="0"/>
           </a:p>
@@ -3540,7 +3540,7 @@
                 <a:ea typeface="Aptos" pitchFamily="34" charset="-122"/>
                 <a:cs typeface="Aptos" pitchFamily="34" charset="-120"/>
               </a:rPr>
-              <a:t>Working: beats regional NE and ACD on basal area</a:t>
+              <a:t>Mortality, crown, HT-DBH calibrated for all 25 variants; growth in progress</a:t>
             </a:r>
             <a:endParaRPr lang="en-US" sz="1350" dirty="0"/>
           </a:p>
@@ -3756,7 +3756,7 @@
                 <a:ea typeface="Aptos" pitchFamily="34" charset="-122"/>
                 <a:cs typeface="Aptos" pitchFamily="34" charset="-120"/>
               </a:rPr>
-              <a:t>Validated: better self-thinning in 19 of 20 variants</a:t>
+              <a:t>Validated in analysis; not yet in production config</a:t>
             </a:r>
             <a:endParaRPr lang="en-US" sz="1350" dirty="0"/>
           </a:p>
@@ -3972,7 +3972,7 @@
                 <a:ea typeface="Aptos" pitchFamily="34" charset="-122"/>
                 <a:cs typeface="Aptos" pitchFamily="34" charset="-120"/>
               </a:rPr>
-              <a:t>In progress: components built, integration next</a:t>
+              <a:t>Equations banked; injection prototyped, not merged</a:t>
             </a:r>
             <a:endParaRPr lang="en-US" sz="1350" dirty="0"/>
           </a:p>
@@ -4658,7 +4658,7 @@
                 <a:ea typeface="Aptos" pitchFamily="34" charset="-122"/>
                 <a:cs typeface="Aptos" pitchFamily="34" charset="-120"/>
               </a:rPr>
-              <a:t>Calibrated FVS already beats the regional variants on basal area in the Northeast</a:t>
+              <a:t>Early Northeast result is encouraging; being re-verified, and growth calibration is in progress</a:t>
             </a:r>
             <a:endParaRPr lang="en-US" sz="1800" dirty="0"/>
           </a:p>

</xml_diff>